<commit_message>
feat(presentation): add "Take it with you" QR slide to bundled Data Mesh decks
Appended directly to the two source-less Data Mesh pptx copies in this repo.
Left QR -> the datamesh-reference-arch-python site, right QR -> the hub.
</commit_message>
<xml_diff>
--- a/presentation/data-mesh-101/The_Data_Mesh_Updated.pptx
+++ b/presentation/data-mesh-101/The_Data_Mesh_Updated.pptx
@@ -45,6 +45,7 @@
     <p:sldId id="293" r:id="rId39"/>
     <p:sldId id="294" r:id="rId40"/>
     <p:sldId id="295" r:id="rId41"/>
+    <p:sldId id="296" r:id="rId47"/>
   </p:sldIdLst>
   <p:notesMasterIdLst>
     <p:notesMasterId r:id="rId42"/>
@@ -14352,6 +14353,428 @@
 </p:sld>
 </file>
 
+<file path=ppt/slides/slide41.xml><?xml version="1.0" encoding="utf-8"?>
+<p:sld xmlns:a="http://schemas.openxmlformats.org/drawingml/2006/main" xmlns:p="http://schemas.openxmlformats.org/presentationml/2006/main" xmlns:r="http://schemas.openxmlformats.org/officeDocument/2006/relationships">
+  <p:bg>
+    <p:bgPr>
+      <a:solidFill>
+        <a:srgbClr val="FFFFFF"/>
+      </a:solidFill>
+      <a:effectLst/>
+    </p:bgPr>
+  </p:bg>
+  <p:cSld>
+    <p:spTree>
+      <p:nvGrpSpPr>
+        <p:cNvPr id="1" name=""/>
+        <p:cNvGrpSpPr/>
+        <p:nvPr/>
+      </p:nvGrpSpPr>
+      <p:grpSpPr/>
+      <p:sp>
+        <p:nvSpPr>
+          <p:cNvPr id="2" name="TextBox 1"/>
+          <p:cNvSpPr txBox="1"/>
+          <p:nvPr/>
+        </p:nvSpPr>
+        <p:spPr>
+          <a:xfrm>
+            <a:off x="425206" y="288043"/>
+            <a:ext cx="8291529" cy="219461"/>
+          </a:xfrm>
+          <a:prstGeom prst="rect">
+            <a:avLst/>
+          </a:prstGeom>
+          <a:noFill/>
+        </p:spPr>
+        <p:txBody>
+          <a:bodyPr wrap="square" lIns="0" rIns="0" tIns="0" bIns="0" anchor="ctr">
+            <a:spAutoFit/>
+          </a:bodyPr>
+          <a:lstStyle/>
+          <a:p>
+            <a:pPr algn="l"/>
+            <a:r>
+              <a:rPr sz="900" b="1" i="0" spc="300">
+                <a:solidFill>
+                  <a:srgbClr val="EE0000"/>
+                </a:solidFill>
+                <a:latin typeface="Overpass"/>
+                <a:cs typeface="Overpass"/>
+              </a:rPr>
+              <a:t>SCAN TO EXPLORE</a:t>
+            </a:r>
+          </a:p>
+        </p:txBody>
+      </p:sp>
+      <p:sp>
+        <p:nvSpPr>
+          <p:cNvPr id="3" name="TextBox 2"/>
+          <p:cNvSpPr txBox="1"/>
+          <p:nvPr/>
+        </p:nvSpPr>
+        <p:spPr>
+          <a:xfrm>
+            <a:off x="425206" y="507504"/>
+            <a:ext cx="8291529" cy="754398"/>
+          </a:xfrm>
+          <a:prstGeom prst="rect">
+            <a:avLst/>
+          </a:prstGeom>
+          <a:noFill/>
+        </p:spPr>
+        <p:txBody>
+          <a:bodyPr wrap="square" lIns="0" rIns="0" tIns="0" bIns="0" anchor="t">
+            <a:spAutoFit/>
+          </a:bodyPr>
+          <a:lstStyle/>
+          <a:p>
+            <a:pPr algn="l"/>
+            <a:r>
+              <a:rPr sz="2250" b="1" i="0">
+                <a:solidFill>
+                  <a:srgbClr val="151515"/>
+                </a:solidFill>
+                <a:latin typeface="Overpass"/>
+                <a:cs typeface="Overpass"/>
+              </a:rPr>
+              <a:t>Take it with you</a:t>
+            </a:r>
+          </a:p>
+        </p:txBody>
+      </p:sp>
+      <p:pic>
+        <p:nvPicPr>
+          <p:cNvPr id="4" name="Picture 3" descr="qr-dmpy-site.png"/>
+          <p:cNvPicPr>
+            <a:picLocks noChangeAspect="1"/>
+          </p:cNvPicPr>
+          <p:nvPr/>
+        </p:nvPicPr>
+        <p:blipFill>
+          <a:blip r:embed="rId2"/>
+          <a:stretch>
+            <a:fillRect/>
+          </a:stretch>
+        </p:blipFill>
+        <p:spPr>
+          <a:xfrm>
+            <a:off x="1577379" y="1220754"/>
+            <a:ext cx="2126033" cy="2126033"/>
+          </a:xfrm>
+          <a:prstGeom prst="rect">
+            <a:avLst/>
+          </a:prstGeom>
+        </p:spPr>
+      </p:pic>
+      <p:sp>
+        <p:nvSpPr>
+          <p:cNvPr id="5" name="TextBox 4"/>
+          <p:cNvSpPr txBox="1"/>
+          <p:nvPr/>
+        </p:nvSpPr>
+        <p:spPr>
+          <a:xfrm>
+            <a:off x="1063016" y="3415369"/>
+            <a:ext cx="3154758" cy="274326"/>
+          </a:xfrm>
+          <a:prstGeom prst="rect">
+            <a:avLst/>
+          </a:prstGeom>
+          <a:noFill/>
+        </p:spPr>
+        <p:txBody>
+          <a:bodyPr wrap="square" lIns="0" rIns="0" tIns="0" bIns="0" anchor="ctr">
+            <a:spAutoFit/>
+          </a:bodyPr>
+          <a:lstStyle/>
+          <a:p>
+            <a:pPr algn="ctr"/>
+            <a:r>
+              <a:rPr sz="1350" b="1" i="0">
+                <a:solidFill>
+                  <a:srgbClr val="151515"/>
+                </a:solidFill>
+                <a:latin typeface="Overpass"/>
+                <a:cs typeface="Overpass"/>
+              </a:rPr>
+              <a:t>The reference architecture</a:t>
+            </a:r>
+          </a:p>
+        </p:txBody>
+      </p:sp>
+      <p:sp>
+        <p:nvSpPr>
+          <p:cNvPr id="6" name="TextBox 5"/>
+          <p:cNvSpPr txBox="1"/>
+          <p:nvPr/>
+        </p:nvSpPr>
+        <p:spPr>
+          <a:xfrm>
+            <a:off x="994434" y="3703412"/>
+            <a:ext cx="3291922" cy="493788"/>
+          </a:xfrm>
+          <a:prstGeom prst="rect">
+            <a:avLst/>
+          </a:prstGeom>
+          <a:noFill/>
+        </p:spPr>
+        <p:txBody>
+          <a:bodyPr wrap="square" lIns="0" rIns="0" tIns="0" bIns="0" anchor="t">
+            <a:spAutoFit/>
+          </a:bodyPr>
+          <a:lstStyle/>
+          <a:p>
+            <a:pPr algn="ctr"/>
+            <a:r>
+              <a:rPr sz="975" b="0" i="1">
+                <a:solidFill>
+                  <a:srgbClr val="5A5A5A"/>
+                </a:solidFill>
+                <a:latin typeface="Red Hat Text"/>
+                <a:cs typeface="Red Hat Text"/>
+              </a:rPr>
+              <a:t>Site, runnable Python services, contracts, and the minikube bootstrap</a:t>
+            </a:r>
+          </a:p>
+        </p:txBody>
+      </p:sp>
+      <p:sp>
+        <p:nvSpPr>
+          <p:cNvPr id="7" name="TextBox 6"/>
+          <p:cNvSpPr txBox="1"/>
+          <p:nvPr/>
+        </p:nvSpPr>
+        <p:spPr>
+          <a:xfrm>
+            <a:off x="994434" y="4197200"/>
+            <a:ext cx="3291922" cy="219461"/>
+          </a:xfrm>
+          <a:prstGeom prst="rect">
+            <a:avLst/>
+          </a:prstGeom>
+          <a:noFill/>
+        </p:spPr>
+        <p:txBody>
+          <a:bodyPr wrap="square" lIns="0" rIns="0" tIns="0" bIns="0" anchor="ctr">
+            <a:spAutoFit/>
+          </a:bodyPr>
+          <a:lstStyle/>
+          <a:p>
+            <a:pPr algn="ctr"/>
+            <a:r>
+              <a:rPr sz="750" b="0" i="0">
+                <a:solidFill>
+                  <a:srgbClr val="EE0000"/>
+                </a:solidFill>
+                <a:latin typeface="Red Hat Mono"/>
+                <a:cs typeface="Red Hat Mono"/>
+              </a:rPr>
+              <a:t>patterncatalyst.github.io/datamesh-reference-arch-python</a:t>
+            </a:r>
+          </a:p>
+        </p:txBody>
+      </p:sp>
+      <p:pic>
+        <p:nvPicPr>
+          <p:cNvPr id="8" name="Picture 7" descr="qr-hub.png"/>
+          <p:cNvPicPr>
+            <a:picLocks noChangeAspect="1"/>
+          </p:cNvPicPr>
+          <p:nvPr/>
+        </p:nvPicPr>
+        <p:blipFill>
+          <a:blip r:embed="rId3"/>
+          <a:stretch>
+            <a:fillRect/>
+          </a:stretch>
+        </p:blipFill>
+        <p:spPr>
+          <a:xfrm>
+            <a:off x="5438529" y="1220754"/>
+            <a:ext cx="2126033" cy="2126033"/>
+          </a:xfrm>
+          <a:prstGeom prst="rect">
+            <a:avLst/>
+          </a:prstGeom>
+        </p:spPr>
+      </p:pic>
+      <p:sp>
+        <p:nvSpPr>
+          <p:cNvPr id="9" name="TextBox 8"/>
+          <p:cNvSpPr txBox="1"/>
+          <p:nvPr/>
+        </p:nvSpPr>
+        <p:spPr>
+          <a:xfrm>
+            <a:off x="4924167" y="3415369"/>
+            <a:ext cx="3154758" cy="274326"/>
+          </a:xfrm>
+          <a:prstGeom prst="rect">
+            <a:avLst/>
+          </a:prstGeom>
+          <a:noFill/>
+        </p:spPr>
+        <p:txBody>
+          <a:bodyPr wrap="square" lIns="0" rIns="0" tIns="0" bIns="0" anchor="ctr">
+            <a:spAutoFit/>
+          </a:bodyPr>
+          <a:lstStyle/>
+          <a:p>
+            <a:pPr algn="ctr"/>
+            <a:r>
+              <a:rPr sz="1350" b="1" i="0">
+                <a:solidFill>
+                  <a:srgbClr val="151515"/>
+                </a:solidFill>
+                <a:latin typeface="Overpass"/>
+                <a:cs typeface="Overpass"/>
+              </a:rPr>
+              <a:t>Workshops &amp; Tutorials</a:t>
+            </a:r>
+          </a:p>
+        </p:txBody>
+      </p:sp>
+      <p:sp>
+        <p:nvSpPr>
+          <p:cNvPr id="10" name="TextBox 9"/>
+          <p:cNvSpPr txBox="1"/>
+          <p:nvPr/>
+        </p:nvSpPr>
+        <p:spPr>
+          <a:xfrm>
+            <a:off x="4855585" y="3703412"/>
+            <a:ext cx="3291922" cy="493788"/>
+          </a:xfrm>
+          <a:prstGeom prst="rect">
+            <a:avLst/>
+          </a:prstGeom>
+          <a:noFill/>
+        </p:spPr>
+        <p:txBody>
+          <a:bodyPr wrap="square" lIns="0" rIns="0" tIns="0" bIns="0" anchor="t">
+            <a:spAutoFit/>
+          </a:bodyPr>
+          <a:lstStyle/>
+          <a:p>
+            <a:pPr algn="ctr"/>
+            <a:r>
+              <a:rPr sz="975" b="0" i="1">
+                <a:solidFill>
+                  <a:srgbClr val="5A5A5A"/>
+                </a:solidFill>
+                <a:latin typeface="Red Hat Text"/>
+                <a:cs typeface="Red Hat Text"/>
+              </a:rPr>
+              <a:t>The whole series: every workshop, tutorial, and deck in one place</a:t>
+            </a:r>
+          </a:p>
+        </p:txBody>
+      </p:sp>
+      <p:sp>
+        <p:nvSpPr>
+          <p:cNvPr id="11" name="TextBox 10"/>
+          <p:cNvSpPr txBox="1"/>
+          <p:nvPr/>
+        </p:nvSpPr>
+        <p:spPr>
+          <a:xfrm>
+            <a:off x="4855585" y="4197200"/>
+            <a:ext cx="3291922" cy="219461"/>
+          </a:xfrm>
+          <a:prstGeom prst="rect">
+            <a:avLst/>
+          </a:prstGeom>
+          <a:noFill/>
+        </p:spPr>
+        <p:txBody>
+          <a:bodyPr wrap="square" lIns="0" rIns="0" tIns="0" bIns="0" anchor="ctr">
+            <a:spAutoFit/>
+          </a:bodyPr>
+          <a:lstStyle/>
+          <a:p>
+            <a:pPr algn="ctr"/>
+            <a:r>
+              <a:rPr sz="675" b="0" i="0">
+                <a:solidFill>
+                  <a:srgbClr val="EE0000"/>
+                </a:solidFill>
+                <a:latin typeface="Red Hat Mono"/>
+                <a:cs typeface="Red Hat Mono"/>
+              </a:rPr>
+              <a:t>patterncatalyst.github.io/patterncatalyst-workshops-tutorials-list</a:t>
+            </a:r>
+          </a:p>
+        </p:txBody>
+      </p:sp>
+      <p:sp>
+        <p:nvSpPr>
+          <p:cNvPr id="12" name="TextBox 11"/>
+          <p:cNvSpPr txBox="1"/>
+          <p:nvPr/>
+        </p:nvSpPr>
+        <p:spPr>
+          <a:xfrm>
+            <a:off x="425206" y="4773287"/>
+            <a:ext cx="685817" cy="205745"/>
+          </a:xfrm>
+          <a:prstGeom prst="rect">
+            <a:avLst/>
+          </a:prstGeom>
+          <a:noFill/>
+        </p:spPr>
+        <p:txBody>
+          <a:bodyPr wrap="square" lIns="0" rIns="0" tIns="0" bIns="0" anchor="ctr">
+            <a:spAutoFit/>
+          </a:bodyPr>
+          <a:lstStyle/>
+          <a:p>
+            <a:pPr algn="l"/>
+            <a:r>
+              <a:rPr sz="750" b="0" i="0">
+                <a:solidFill>
+                  <a:srgbClr val="8A8A8A"/>
+                </a:solidFill>
+                <a:latin typeface="Red Hat Text"/>
+                <a:cs typeface="Red Hat Text"/>
+              </a:rPr>
+              <a:t>41</a:t>
+            </a:r>
+          </a:p>
+        </p:txBody>
+      </p:sp>
+      <p:pic>
+        <p:nvPicPr>
+          <p:cNvPr id="13" name="Picture 12" descr="image.png"/>
+          <p:cNvPicPr>
+            <a:picLocks noChangeAspect="1"/>
+          </p:cNvPicPr>
+          <p:nvPr/>
+        </p:nvPicPr>
+        <p:blipFill>
+          <a:blip r:embed="rId4"/>
+          <a:stretch>
+            <a:fillRect/>
+          </a:stretch>
+        </p:blipFill>
+        <p:spPr>
+          <a:xfrm>
+            <a:off x="7921188" y="4766429"/>
+            <a:ext cx="774973" cy="185170"/>
+          </a:xfrm>
+          <a:prstGeom prst="rect">
+            <a:avLst/>
+          </a:prstGeom>
+        </p:spPr>
+      </p:pic>
+    </p:spTree>
+  </p:cSld>
+  <p:clrMapOvr>
+    <a:masterClrMapping/>
+  </p:clrMapOvr>
+</p:sld>
+</file>
+
 <file path=ppt/slides/slide5.xml><?xml version="1.0" encoding="utf-8"?>
 <p:sld xmlns:a="http://schemas.openxmlformats.org/drawingml/2006/main" xmlns:r="http://schemas.openxmlformats.org/officeDocument/2006/relationships" xmlns:p="http://schemas.openxmlformats.org/presentationml/2006/main">
   <p:cSld name="Slide 5">

</xml_diff>

<commit_message>
feat(presentation): add "Take it with you" QR slide to bundled Data Mesh decks (#2)
Appended directly to the two source-less Data Mesh pptx copies in this repo.
Left QR -> the datamesh-reference-arch-python site, right QR -> the hub.
</commit_message>
<xml_diff>
--- a/presentation/data-mesh-101/The_Data_Mesh_Updated.pptx
+++ b/presentation/data-mesh-101/The_Data_Mesh_Updated.pptx
@@ -45,6 +45,7 @@
     <p:sldId id="293" r:id="rId39"/>
     <p:sldId id="294" r:id="rId40"/>
     <p:sldId id="295" r:id="rId41"/>
+    <p:sldId id="296" r:id="rId47"/>
   </p:sldIdLst>
   <p:notesMasterIdLst>
     <p:notesMasterId r:id="rId42"/>
@@ -14352,6 +14353,428 @@
 </p:sld>
 </file>
 
+<file path=ppt/slides/slide41.xml><?xml version="1.0" encoding="utf-8"?>
+<p:sld xmlns:a="http://schemas.openxmlformats.org/drawingml/2006/main" xmlns:p="http://schemas.openxmlformats.org/presentationml/2006/main" xmlns:r="http://schemas.openxmlformats.org/officeDocument/2006/relationships">
+  <p:bg>
+    <p:bgPr>
+      <a:solidFill>
+        <a:srgbClr val="FFFFFF"/>
+      </a:solidFill>
+      <a:effectLst/>
+    </p:bgPr>
+  </p:bg>
+  <p:cSld>
+    <p:spTree>
+      <p:nvGrpSpPr>
+        <p:cNvPr id="1" name=""/>
+        <p:cNvGrpSpPr/>
+        <p:nvPr/>
+      </p:nvGrpSpPr>
+      <p:grpSpPr/>
+      <p:sp>
+        <p:nvSpPr>
+          <p:cNvPr id="2" name="TextBox 1"/>
+          <p:cNvSpPr txBox="1"/>
+          <p:nvPr/>
+        </p:nvSpPr>
+        <p:spPr>
+          <a:xfrm>
+            <a:off x="425206" y="288043"/>
+            <a:ext cx="8291529" cy="219461"/>
+          </a:xfrm>
+          <a:prstGeom prst="rect">
+            <a:avLst/>
+          </a:prstGeom>
+          <a:noFill/>
+        </p:spPr>
+        <p:txBody>
+          <a:bodyPr wrap="square" lIns="0" rIns="0" tIns="0" bIns="0" anchor="ctr">
+            <a:spAutoFit/>
+          </a:bodyPr>
+          <a:lstStyle/>
+          <a:p>
+            <a:pPr algn="l"/>
+            <a:r>
+              <a:rPr sz="900" b="1" i="0" spc="300">
+                <a:solidFill>
+                  <a:srgbClr val="EE0000"/>
+                </a:solidFill>
+                <a:latin typeface="Overpass"/>
+                <a:cs typeface="Overpass"/>
+              </a:rPr>
+              <a:t>SCAN TO EXPLORE</a:t>
+            </a:r>
+          </a:p>
+        </p:txBody>
+      </p:sp>
+      <p:sp>
+        <p:nvSpPr>
+          <p:cNvPr id="3" name="TextBox 2"/>
+          <p:cNvSpPr txBox="1"/>
+          <p:nvPr/>
+        </p:nvSpPr>
+        <p:spPr>
+          <a:xfrm>
+            <a:off x="425206" y="507504"/>
+            <a:ext cx="8291529" cy="754398"/>
+          </a:xfrm>
+          <a:prstGeom prst="rect">
+            <a:avLst/>
+          </a:prstGeom>
+          <a:noFill/>
+        </p:spPr>
+        <p:txBody>
+          <a:bodyPr wrap="square" lIns="0" rIns="0" tIns="0" bIns="0" anchor="t">
+            <a:spAutoFit/>
+          </a:bodyPr>
+          <a:lstStyle/>
+          <a:p>
+            <a:pPr algn="l"/>
+            <a:r>
+              <a:rPr sz="2250" b="1" i="0">
+                <a:solidFill>
+                  <a:srgbClr val="151515"/>
+                </a:solidFill>
+                <a:latin typeface="Overpass"/>
+                <a:cs typeface="Overpass"/>
+              </a:rPr>
+              <a:t>Take it with you</a:t>
+            </a:r>
+          </a:p>
+        </p:txBody>
+      </p:sp>
+      <p:pic>
+        <p:nvPicPr>
+          <p:cNvPr id="4" name="Picture 3" descr="qr-dmpy-site.png"/>
+          <p:cNvPicPr>
+            <a:picLocks noChangeAspect="1"/>
+          </p:cNvPicPr>
+          <p:nvPr/>
+        </p:nvPicPr>
+        <p:blipFill>
+          <a:blip r:embed="rId2"/>
+          <a:stretch>
+            <a:fillRect/>
+          </a:stretch>
+        </p:blipFill>
+        <p:spPr>
+          <a:xfrm>
+            <a:off x="1577379" y="1220754"/>
+            <a:ext cx="2126033" cy="2126033"/>
+          </a:xfrm>
+          <a:prstGeom prst="rect">
+            <a:avLst/>
+          </a:prstGeom>
+        </p:spPr>
+      </p:pic>
+      <p:sp>
+        <p:nvSpPr>
+          <p:cNvPr id="5" name="TextBox 4"/>
+          <p:cNvSpPr txBox="1"/>
+          <p:nvPr/>
+        </p:nvSpPr>
+        <p:spPr>
+          <a:xfrm>
+            <a:off x="1063016" y="3415369"/>
+            <a:ext cx="3154758" cy="274326"/>
+          </a:xfrm>
+          <a:prstGeom prst="rect">
+            <a:avLst/>
+          </a:prstGeom>
+          <a:noFill/>
+        </p:spPr>
+        <p:txBody>
+          <a:bodyPr wrap="square" lIns="0" rIns="0" tIns="0" bIns="0" anchor="ctr">
+            <a:spAutoFit/>
+          </a:bodyPr>
+          <a:lstStyle/>
+          <a:p>
+            <a:pPr algn="ctr"/>
+            <a:r>
+              <a:rPr sz="1350" b="1" i="0">
+                <a:solidFill>
+                  <a:srgbClr val="151515"/>
+                </a:solidFill>
+                <a:latin typeface="Overpass"/>
+                <a:cs typeface="Overpass"/>
+              </a:rPr>
+              <a:t>The reference architecture</a:t>
+            </a:r>
+          </a:p>
+        </p:txBody>
+      </p:sp>
+      <p:sp>
+        <p:nvSpPr>
+          <p:cNvPr id="6" name="TextBox 5"/>
+          <p:cNvSpPr txBox="1"/>
+          <p:nvPr/>
+        </p:nvSpPr>
+        <p:spPr>
+          <a:xfrm>
+            <a:off x="994434" y="3703412"/>
+            <a:ext cx="3291922" cy="493788"/>
+          </a:xfrm>
+          <a:prstGeom prst="rect">
+            <a:avLst/>
+          </a:prstGeom>
+          <a:noFill/>
+        </p:spPr>
+        <p:txBody>
+          <a:bodyPr wrap="square" lIns="0" rIns="0" tIns="0" bIns="0" anchor="t">
+            <a:spAutoFit/>
+          </a:bodyPr>
+          <a:lstStyle/>
+          <a:p>
+            <a:pPr algn="ctr"/>
+            <a:r>
+              <a:rPr sz="975" b="0" i="1">
+                <a:solidFill>
+                  <a:srgbClr val="5A5A5A"/>
+                </a:solidFill>
+                <a:latin typeface="Red Hat Text"/>
+                <a:cs typeface="Red Hat Text"/>
+              </a:rPr>
+              <a:t>Site, runnable Python services, contracts, and the minikube bootstrap</a:t>
+            </a:r>
+          </a:p>
+        </p:txBody>
+      </p:sp>
+      <p:sp>
+        <p:nvSpPr>
+          <p:cNvPr id="7" name="TextBox 6"/>
+          <p:cNvSpPr txBox="1"/>
+          <p:nvPr/>
+        </p:nvSpPr>
+        <p:spPr>
+          <a:xfrm>
+            <a:off x="994434" y="4197200"/>
+            <a:ext cx="3291922" cy="219461"/>
+          </a:xfrm>
+          <a:prstGeom prst="rect">
+            <a:avLst/>
+          </a:prstGeom>
+          <a:noFill/>
+        </p:spPr>
+        <p:txBody>
+          <a:bodyPr wrap="square" lIns="0" rIns="0" tIns="0" bIns="0" anchor="ctr">
+            <a:spAutoFit/>
+          </a:bodyPr>
+          <a:lstStyle/>
+          <a:p>
+            <a:pPr algn="ctr"/>
+            <a:r>
+              <a:rPr sz="750" b="0" i="0">
+                <a:solidFill>
+                  <a:srgbClr val="EE0000"/>
+                </a:solidFill>
+                <a:latin typeface="Red Hat Mono"/>
+                <a:cs typeface="Red Hat Mono"/>
+              </a:rPr>
+              <a:t>patterncatalyst.github.io/datamesh-reference-arch-python</a:t>
+            </a:r>
+          </a:p>
+        </p:txBody>
+      </p:sp>
+      <p:pic>
+        <p:nvPicPr>
+          <p:cNvPr id="8" name="Picture 7" descr="qr-hub.png"/>
+          <p:cNvPicPr>
+            <a:picLocks noChangeAspect="1"/>
+          </p:cNvPicPr>
+          <p:nvPr/>
+        </p:nvPicPr>
+        <p:blipFill>
+          <a:blip r:embed="rId3"/>
+          <a:stretch>
+            <a:fillRect/>
+          </a:stretch>
+        </p:blipFill>
+        <p:spPr>
+          <a:xfrm>
+            <a:off x="5438529" y="1220754"/>
+            <a:ext cx="2126033" cy="2126033"/>
+          </a:xfrm>
+          <a:prstGeom prst="rect">
+            <a:avLst/>
+          </a:prstGeom>
+        </p:spPr>
+      </p:pic>
+      <p:sp>
+        <p:nvSpPr>
+          <p:cNvPr id="9" name="TextBox 8"/>
+          <p:cNvSpPr txBox="1"/>
+          <p:nvPr/>
+        </p:nvSpPr>
+        <p:spPr>
+          <a:xfrm>
+            <a:off x="4924167" y="3415369"/>
+            <a:ext cx="3154758" cy="274326"/>
+          </a:xfrm>
+          <a:prstGeom prst="rect">
+            <a:avLst/>
+          </a:prstGeom>
+          <a:noFill/>
+        </p:spPr>
+        <p:txBody>
+          <a:bodyPr wrap="square" lIns="0" rIns="0" tIns="0" bIns="0" anchor="ctr">
+            <a:spAutoFit/>
+          </a:bodyPr>
+          <a:lstStyle/>
+          <a:p>
+            <a:pPr algn="ctr"/>
+            <a:r>
+              <a:rPr sz="1350" b="1" i="0">
+                <a:solidFill>
+                  <a:srgbClr val="151515"/>
+                </a:solidFill>
+                <a:latin typeface="Overpass"/>
+                <a:cs typeface="Overpass"/>
+              </a:rPr>
+              <a:t>Workshops &amp; Tutorials</a:t>
+            </a:r>
+          </a:p>
+        </p:txBody>
+      </p:sp>
+      <p:sp>
+        <p:nvSpPr>
+          <p:cNvPr id="10" name="TextBox 9"/>
+          <p:cNvSpPr txBox="1"/>
+          <p:nvPr/>
+        </p:nvSpPr>
+        <p:spPr>
+          <a:xfrm>
+            <a:off x="4855585" y="3703412"/>
+            <a:ext cx="3291922" cy="493788"/>
+          </a:xfrm>
+          <a:prstGeom prst="rect">
+            <a:avLst/>
+          </a:prstGeom>
+          <a:noFill/>
+        </p:spPr>
+        <p:txBody>
+          <a:bodyPr wrap="square" lIns="0" rIns="0" tIns="0" bIns="0" anchor="t">
+            <a:spAutoFit/>
+          </a:bodyPr>
+          <a:lstStyle/>
+          <a:p>
+            <a:pPr algn="ctr"/>
+            <a:r>
+              <a:rPr sz="975" b="0" i="1">
+                <a:solidFill>
+                  <a:srgbClr val="5A5A5A"/>
+                </a:solidFill>
+                <a:latin typeface="Red Hat Text"/>
+                <a:cs typeface="Red Hat Text"/>
+              </a:rPr>
+              <a:t>The whole series: every workshop, tutorial, and deck in one place</a:t>
+            </a:r>
+          </a:p>
+        </p:txBody>
+      </p:sp>
+      <p:sp>
+        <p:nvSpPr>
+          <p:cNvPr id="11" name="TextBox 10"/>
+          <p:cNvSpPr txBox="1"/>
+          <p:nvPr/>
+        </p:nvSpPr>
+        <p:spPr>
+          <a:xfrm>
+            <a:off x="4855585" y="4197200"/>
+            <a:ext cx="3291922" cy="219461"/>
+          </a:xfrm>
+          <a:prstGeom prst="rect">
+            <a:avLst/>
+          </a:prstGeom>
+          <a:noFill/>
+        </p:spPr>
+        <p:txBody>
+          <a:bodyPr wrap="square" lIns="0" rIns="0" tIns="0" bIns="0" anchor="ctr">
+            <a:spAutoFit/>
+          </a:bodyPr>
+          <a:lstStyle/>
+          <a:p>
+            <a:pPr algn="ctr"/>
+            <a:r>
+              <a:rPr sz="675" b="0" i="0">
+                <a:solidFill>
+                  <a:srgbClr val="EE0000"/>
+                </a:solidFill>
+                <a:latin typeface="Red Hat Mono"/>
+                <a:cs typeface="Red Hat Mono"/>
+              </a:rPr>
+              <a:t>patterncatalyst.github.io/patterncatalyst-workshops-tutorials-list</a:t>
+            </a:r>
+          </a:p>
+        </p:txBody>
+      </p:sp>
+      <p:sp>
+        <p:nvSpPr>
+          <p:cNvPr id="12" name="TextBox 11"/>
+          <p:cNvSpPr txBox="1"/>
+          <p:nvPr/>
+        </p:nvSpPr>
+        <p:spPr>
+          <a:xfrm>
+            <a:off x="425206" y="4773287"/>
+            <a:ext cx="685817" cy="205745"/>
+          </a:xfrm>
+          <a:prstGeom prst="rect">
+            <a:avLst/>
+          </a:prstGeom>
+          <a:noFill/>
+        </p:spPr>
+        <p:txBody>
+          <a:bodyPr wrap="square" lIns="0" rIns="0" tIns="0" bIns="0" anchor="ctr">
+            <a:spAutoFit/>
+          </a:bodyPr>
+          <a:lstStyle/>
+          <a:p>
+            <a:pPr algn="l"/>
+            <a:r>
+              <a:rPr sz="750" b="0" i="0">
+                <a:solidFill>
+                  <a:srgbClr val="8A8A8A"/>
+                </a:solidFill>
+                <a:latin typeface="Red Hat Text"/>
+                <a:cs typeface="Red Hat Text"/>
+              </a:rPr>
+              <a:t>41</a:t>
+            </a:r>
+          </a:p>
+        </p:txBody>
+      </p:sp>
+      <p:pic>
+        <p:nvPicPr>
+          <p:cNvPr id="13" name="Picture 12" descr="image.png"/>
+          <p:cNvPicPr>
+            <a:picLocks noChangeAspect="1"/>
+          </p:cNvPicPr>
+          <p:nvPr/>
+        </p:nvPicPr>
+        <p:blipFill>
+          <a:blip r:embed="rId4"/>
+          <a:stretch>
+            <a:fillRect/>
+          </a:stretch>
+        </p:blipFill>
+        <p:spPr>
+          <a:xfrm>
+            <a:off x="7921188" y="4766429"/>
+            <a:ext cx="774973" cy="185170"/>
+          </a:xfrm>
+          <a:prstGeom prst="rect">
+            <a:avLst/>
+          </a:prstGeom>
+        </p:spPr>
+      </p:pic>
+    </p:spTree>
+  </p:cSld>
+  <p:clrMapOvr>
+    <a:masterClrMapping/>
+  </p:clrMapOvr>
+</p:sld>
+</file>
+
 <file path=ppt/slides/slide5.xml><?xml version="1.0" encoding="utf-8"?>
 <p:sld xmlns:a="http://schemas.openxmlformats.org/drawingml/2006/main" xmlns:r="http://schemas.openxmlformats.org/officeDocument/2006/relationships" xmlns:p="http://schemas.openxmlformats.org/presentationml/2006/main">
   <p:cSld name="Slide 5">

</xml_diff>